<commit_message>
Ajusta documentacao e slides para autoria individual
Remove linhas de placeholder para outros integrantes (README e slide de
autor da apresentacao), corrige o passo a passo de execucao para incluir
o git clone e o cd na pasta correta do repositorio, e ajusta o roteiro
do pitch para fala em primeira pessoa (trabalho individual).
</commit_message>
<xml_diff>
--- a/docs/slides/leroy-merlin-smart-hub.pptx
+++ b/docs/slides/leroy-merlin-smart-hub.pptx
@@ -5604,7 +5604,7 @@
                 <a:ea typeface="Cambria" pitchFamily="34" charset="-122"/>
                 <a:cs typeface="Cambria" pitchFamily="34" charset="-120"/>
               </a:rPr>
-              <a:t>Equipe</a:t>
+              <a:t>Autor</a:t>
             </a:r>
             <a:endParaRPr lang="en-US" sz="3200" dirty="0"/>
           </a:p>
@@ -5618,12 +5618,12 @@
         </p:nvSpPr>
         <p:spPr>
           <a:xfrm>
-            <a:off x="640080" y="1691640"/>
-            <a:ext cx="2606040" cy="3291840"/>
+            <a:off x="3259836" y="1737360"/>
+            <a:ext cx="5669280" cy="3200400"/>
           </a:xfrm>
           <a:prstGeom prst="roundRect">
             <a:avLst>
-              <a:gd name="adj" fmla="val 3509"/>
+              <a:gd name="adj" fmla="val 2857"/>
             </a:avLst>
           </a:prstGeom>
           <a:solidFill>
@@ -5645,8 +5645,8 @@
         </p:nvSpPr>
         <p:spPr>
           <a:xfrm>
-            <a:off x="1348740" y="2011680"/>
-            <a:ext cx="1188720" cy="1188720"/>
+            <a:off x="5271516" y="2148840"/>
+            <a:ext cx="1645920" cy="1645920"/>
           </a:xfrm>
           <a:prstGeom prst="ellipse">
             <a:avLst/>
@@ -5665,8 +5665,8 @@
         </p:nvSpPr>
         <p:spPr>
           <a:xfrm>
-            <a:off x="1348740" y="2011680"/>
-            <a:ext cx="1188720" cy="1188720"/>
+            <a:off x="5271516" y="2148840"/>
+            <a:ext cx="1645920" cy="1645920"/>
           </a:xfrm>
           <a:prstGeom prst="rect">
             <a:avLst/>
@@ -5682,7 +5682,7 @@
               <a:buNone/>
             </a:pPr>
             <a:r>
-              <a:rPr lang="en-US" sz="2600" b="1" dirty="0">
+              <a:rPr lang="en-US" sz="3400" b="1" dirty="0">
                 <a:solidFill>
                   <a:srgbClr val="FFFFFF"/>
                 </a:solidFill>
@@ -5692,7 +5692,7 @@
               </a:rPr>
               <a:t>LM</a:t>
             </a:r>
-            <a:endParaRPr lang="en-US" sz="2600" dirty="0"/>
+            <a:endParaRPr lang="en-US" sz="3400" dirty="0"/>
           </a:p>
         </p:txBody>
       </p:sp>
@@ -5704,8 +5704,8 @@
         </p:nvSpPr>
         <p:spPr>
           <a:xfrm>
-            <a:off x="777240" y="3383280"/>
-            <a:ext cx="2331720" cy="548640"/>
+            <a:off x="3442716" y="3931920"/>
+            <a:ext cx="5303520" cy="457200"/>
           </a:xfrm>
           <a:prstGeom prst="rect">
             <a:avLst/>
@@ -5721,17 +5721,17 @@
               <a:buNone/>
             </a:pPr>
             <a:r>
-              <a:rPr lang="en-US" sz="1400" b="1" dirty="0">
+              <a:rPr lang="en-US" sz="2000" b="1" dirty="0">
                 <a:solidFill>
                   <a:srgbClr val="14532D"/>
                 </a:solidFill>
-                <a:latin typeface="Calibri" pitchFamily="34" charset="0"/>
-                <a:ea typeface="Calibri" pitchFamily="34" charset="-122"/>
-                <a:cs typeface="Calibri" pitchFamily="34" charset="-120"/>
+                <a:latin typeface="Cambria" pitchFamily="34" charset="0"/>
+                <a:ea typeface="Cambria" pitchFamily="34" charset="-122"/>
+                <a:cs typeface="Cambria" pitchFamily="34" charset="-120"/>
               </a:rPr>
               <a:t>Leonardo Marsiarelli</a:t>
             </a:r>
-            <a:endParaRPr lang="en-US" sz="1400" dirty="0"/>
+            <a:endParaRPr lang="en-US" sz="2000" dirty="0"/>
           </a:p>
         </p:txBody>
       </p:sp>
@@ -5743,8 +5743,8 @@
         </p:nvSpPr>
         <p:spPr>
           <a:xfrm>
-            <a:off x="777240" y="3931920"/>
-            <a:ext cx="2331720" cy="822960"/>
+            <a:off x="3442716" y="4389120"/>
+            <a:ext cx="5303520" cy="457200"/>
           </a:xfrm>
           <a:prstGeom prst="rect">
             <a:avLst/>
@@ -5760,7 +5760,7 @@
               <a:buNone/>
             </a:pPr>
             <a:r>
-              <a:rPr lang="en-US" sz="1250" dirty="0">
+              <a:rPr lang="en-US" sz="1500" dirty="0">
                 <a:solidFill>
                   <a:srgbClr val="5B665E"/>
                 </a:solidFill>
@@ -5768,575 +5768,15 @@
                 <a:ea typeface="Calibri" pitchFamily="34" charset="-122"/>
                 <a:cs typeface="Calibri" pitchFamily="34" charset="-120"/>
               </a:rPr>
-              <a:t>RM 555366</a:t>
-            </a:r>
-            <a:endParaRPr lang="en-US" sz="1250" dirty="0"/>
-          </a:p>
-          <a:p>
-            <a:pPr algn="ctr" indent="0" marL="0">
-              <a:buNone/>
-            </a:pPr>
-            <a:r>
-              <a:rPr lang="en-US" sz="1250" dirty="0">
-                <a:solidFill>
-                  <a:srgbClr val="5B665E"/>
-                </a:solidFill>
-                <a:latin typeface="Calibri" pitchFamily="34" charset="0"/>
-                <a:ea typeface="Calibri" pitchFamily="34" charset="-122"/>
-                <a:cs typeface="Calibri" pitchFamily="34" charset="-120"/>
-              </a:rPr>
-              <a:t>3SIOA</a:t>
-            </a:r>
-            <a:endParaRPr lang="en-US" sz="1250" dirty="0"/>
+              <a:t>RM 555366  ·  Turma 3SIOA</a:t>
+            </a:r>
+            <a:endParaRPr lang="en-US" sz="1500" dirty="0"/>
           </a:p>
         </p:txBody>
       </p:sp>
       <p:sp>
         <p:nvSpPr>
           <p:cNvPr id="8" name="Shape 6"/>
-          <p:cNvSpPr/>
-          <p:nvPr/>
-        </p:nvSpPr>
-        <p:spPr>
-          <a:xfrm>
-            <a:off x="3474720" y="1691640"/>
-            <a:ext cx="2606040" cy="3291840"/>
-          </a:xfrm>
-          <a:prstGeom prst="roundRect">
-            <a:avLst>
-              <a:gd name="adj" fmla="val 3509"/>
-            </a:avLst>
-          </a:prstGeom>
-          <a:solidFill>
-            <a:srgbClr val="F7F7F7"/>
-          </a:solidFill>
-          <a:ln w="12700">
-            <a:solidFill>
-              <a:srgbClr val="D9D9D9"/>
-            </a:solidFill>
-            <a:prstDash val="solid"/>
-          </a:ln>
-        </p:spPr>
-      </p:sp>
-      <p:sp>
-        <p:nvSpPr>
-          <p:cNvPr id="9" name="Shape 7"/>
-          <p:cNvSpPr/>
-          <p:nvPr/>
-        </p:nvSpPr>
-        <p:spPr>
-          <a:xfrm>
-            <a:off x="4183380" y="2011680"/>
-            <a:ext cx="1188720" cy="1188720"/>
-          </a:xfrm>
-          <a:prstGeom prst="ellipse">
-            <a:avLst/>
-          </a:prstGeom>
-          <a:solidFill>
-            <a:srgbClr val="D9D9D9"/>
-          </a:solidFill>
-          <a:ln/>
-        </p:spPr>
-      </p:sp>
-      <p:sp>
-        <p:nvSpPr>
-          <p:cNvPr id="10" name="Text 8"/>
-          <p:cNvSpPr txBox="1"/>
-          <p:nvPr/>
-        </p:nvSpPr>
-        <p:spPr>
-          <a:xfrm>
-            <a:off x="4183380" y="2011680"/>
-            <a:ext cx="1188720" cy="1188720"/>
-          </a:xfrm>
-          <a:prstGeom prst="rect">
-            <a:avLst/>
-          </a:prstGeom>
-          <a:noFill/>
-          <a:ln/>
-        </p:spPr>
-        <p:txBody>
-          <a:bodyPr wrap="square" lIns="0" tIns="0" rIns="0" bIns="0" rtlCol="0" anchor="ctr"/>
-          <a:lstStyle/>
-          <a:p>
-            <a:pPr algn="ctr" indent="0" marL="0">
-              <a:buNone/>
-            </a:pPr>
-            <a:r>
-              <a:rPr lang="en-US" sz="2600" b="1" dirty="0">
-                <a:solidFill>
-                  <a:srgbClr val="FFFFFF"/>
-                </a:solidFill>
-                <a:latin typeface="Calibri" pitchFamily="34" charset="0"/>
-                <a:ea typeface="Calibri" pitchFamily="34" charset="-122"/>
-                <a:cs typeface="Calibri" pitchFamily="34" charset="-120"/>
-              </a:rPr>
-              <a:t>?</a:t>
-            </a:r>
-            <a:endParaRPr lang="en-US" sz="2600" dirty="0"/>
-          </a:p>
-        </p:txBody>
-      </p:sp>
-      <p:sp>
-        <p:nvSpPr>
-          <p:cNvPr id="11" name="Text 9"/>
-          <p:cNvSpPr txBox="1"/>
-          <p:nvPr/>
-        </p:nvSpPr>
-        <p:spPr>
-          <a:xfrm>
-            <a:off x="3611880" y="3383280"/>
-            <a:ext cx="2331720" cy="548640"/>
-          </a:xfrm>
-          <a:prstGeom prst="rect">
-            <a:avLst/>
-          </a:prstGeom>
-          <a:noFill/>
-          <a:ln/>
-        </p:spPr>
-        <p:txBody>
-          <a:bodyPr wrap="square" lIns="0" tIns="0" rIns="0" bIns="0" rtlCol="0" anchor="ctr"/>
-          <a:lstStyle/>
-          <a:p>
-            <a:pPr algn="ctr" indent="0" marL="0">
-              <a:buNone/>
-            </a:pPr>
-            <a:r>
-              <a:rPr lang="en-US" sz="1400" b="1" dirty="0">
-                <a:solidFill>
-                  <a:srgbClr val="5B665E"/>
-                </a:solidFill>
-                <a:latin typeface="Calibri" pitchFamily="34" charset="0"/>
-                <a:ea typeface="Calibri" pitchFamily="34" charset="-122"/>
-                <a:cs typeface="Calibri" pitchFamily="34" charset="-120"/>
-              </a:rPr>
-              <a:t>[Nome completo]</a:t>
-            </a:r>
-            <a:endParaRPr lang="en-US" sz="1400" dirty="0"/>
-          </a:p>
-        </p:txBody>
-      </p:sp>
-      <p:sp>
-        <p:nvSpPr>
-          <p:cNvPr id="12" name="Text 10"/>
-          <p:cNvSpPr txBox="1"/>
-          <p:nvPr/>
-        </p:nvSpPr>
-        <p:spPr>
-          <a:xfrm>
-            <a:off x="3611880" y="3931920"/>
-            <a:ext cx="2331720" cy="822960"/>
-          </a:xfrm>
-          <a:prstGeom prst="rect">
-            <a:avLst/>
-          </a:prstGeom>
-          <a:noFill/>
-          <a:ln/>
-        </p:spPr>
-        <p:txBody>
-          <a:bodyPr wrap="square" lIns="0" tIns="0" rIns="0" bIns="0" rtlCol="0" anchor="ctr"/>
-          <a:lstStyle/>
-          <a:p>
-            <a:pPr algn="ctr" indent="0" marL="0">
-              <a:buNone/>
-            </a:pPr>
-            <a:r>
-              <a:rPr lang="en-US" sz="1250" dirty="0">
-                <a:solidFill>
-                  <a:srgbClr val="5B665E"/>
-                </a:solidFill>
-                <a:latin typeface="Calibri" pitchFamily="34" charset="0"/>
-                <a:ea typeface="Calibri" pitchFamily="34" charset="-122"/>
-                <a:cs typeface="Calibri" pitchFamily="34" charset="-120"/>
-              </a:rPr>
-              <a:t>[RM]</a:t>
-            </a:r>
-            <a:endParaRPr lang="en-US" sz="1250" dirty="0"/>
-          </a:p>
-          <a:p>
-            <a:pPr algn="ctr" indent="0" marL="0">
-              <a:buNone/>
-            </a:pPr>
-            <a:r>
-              <a:rPr lang="en-US" sz="1250" dirty="0">
-                <a:solidFill>
-                  <a:srgbClr val="5B665E"/>
-                </a:solidFill>
-                <a:latin typeface="Calibri" pitchFamily="34" charset="0"/>
-                <a:ea typeface="Calibri" pitchFamily="34" charset="-122"/>
-                <a:cs typeface="Calibri" pitchFamily="34" charset="-120"/>
-              </a:rPr>
-              <a:t>[Turma]</a:t>
-            </a:r>
-            <a:endParaRPr lang="en-US" sz="1250" dirty="0"/>
-          </a:p>
-        </p:txBody>
-      </p:sp>
-      <p:sp>
-        <p:nvSpPr>
-          <p:cNvPr id="13" name="Shape 11"/>
-          <p:cNvSpPr/>
-          <p:nvPr/>
-        </p:nvSpPr>
-        <p:spPr>
-          <a:xfrm>
-            <a:off x="6309360" y="1691640"/>
-            <a:ext cx="2606040" cy="3291840"/>
-          </a:xfrm>
-          <a:prstGeom prst="roundRect">
-            <a:avLst>
-              <a:gd name="adj" fmla="val 3509"/>
-            </a:avLst>
-          </a:prstGeom>
-          <a:solidFill>
-            <a:srgbClr val="F7F7F7"/>
-          </a:solidFill>
-          <a:ln w="12700">
-            <a:solidFill>
-              <a:srgbClr val="D9D9D9"/>
-            </a:solidFill>
-            <a:prstDash val="solid"/>
-          </a:ln>
-        </p:spPr>
-      </p:sp>
-      <p:sp>
-        <p:nvSpPr>
-          <p:cNvPr id="14" name="Shape 12"/>
-          <p:cNvSpPr/>
-          <p:nvPr/>
-        </p:nvSpPr>
-        <p:spPr>
-          <a:xfrm>
-            <a:off x="7018020" y="2011680"/>
-            <a:ext cx="1188720" cy="1188720"/>
-          </a:xfrm>
-          <a:prstGeom prst="ellipse">
-            <a:avLst/>
-          </a:prstGeom>
-          <a:solidFill>
-            <a:srgbClr val="D9D9D9"/>
-          </a:solidFill>
-          <a:ln/>
-        </p:spPr>
-      </p:sp>
-      <p:sp>
-        <p:nvSpPr>
-          <p:cNvPr id="15" name="Text 13"/>
-          <p:cNvSpPr txBox="1"/>
-          <p:nvPr/>
-        </p:nvSpPr>
-        <p:spPr>
-          <a:xfrm>
-            <a:off x="7018020" y="2011680"/>
-            <a:ext cx="1188720" cy="1188720"/>
-          </a:xfrm>
-          <a:prstGeom prst="rect">
-            <a:avLst/>
-          </a:prstGeom>
-          <a:noFill/>
-          <a:ln/>
-        </p:spPr>
-        <p:txBody>
-          <a:bodyPr wrap="square" lIns="0" tIns="0" rIns="0" bIns="0" rtlCol="0" anchor="ctr"/>
-          <a:lstStyle/>
-          <a:p>
-            <a:pPr algn="ctr" indent="0" marL="0">
-              <a:buNone/>
-            </a:pPr>
-            <a:r>
-              <a:rPr lang="en-US" sz="2600" b="1" dirty="0">
-                <a:solidFill>
-                  <a:srgbClr val="FFFFFF"/>
-                </a:solidFill>
-                <a:latin typeface="Calibri" pitchFamily="34" charset="0"/>
-                <a:ea typeface="Calibri" pitchFamily="34" charset="-122"/>
-                <a:cs typeface="Calibri" pitchFamily="34" charset="-120"/>
-              </a:rPr>
-              <a:t>?</a:t>
-            </a:r>
-            <a:endParaRPr lang="en-US" sz="2600" dirty="0"/>
-          </a:p>
-        </p:txBody>
-      </p:sp>
-      <p:sp>
-        <p:nvSpPr>
-          <p:cNvPr id="16" name="Text 14"/>
-          <p:cNvSpPr txBox="1"/>
-          <p:nvPr/>
-        </p:nvSpPr>
-        <p:spPr>
-          <a:xfrm>
-            <a:off x="6446520" y="3383280"/>
-            <a:ext cx="2331720" cy="548640"/>
-          </a:xfrm>
-          <a:prstGeom prst="rect">
-            <a:avLst/>
-          </a:prstGeom>
-          <a:noFill/>
-          <a:ln/>
-        </p:spPr>
-        <p:txBody>
-          <a:bodyPr wrap="square" lIns="0" tIns="0" rIns="0" bIns="0" rtlCol="0" anchor="ctr"/>
-          <a:lstStyle/>
-          <a:p>
-            <a:pPr algn="ctr" indent="0" marL="0">
-              <a:buNone/>
-            </a:pPr>
-            <a:r>
-              <a:rPr lang="en-US" sz="1400" b="1" dirty="0">
-                <a:solidFill>
-                  <a:srgbClr val="5B665E"/>
-                </a:solidFill>
-                <a:latin typeface="Calibri" pitchFamily="34" charset="0"/>
-                <a:ea typeface="Calibri" pitchFamily="34" charset="-122"/>
-                <a:cs typeface="Calibri" pitchFamily="34" charset="-120"/>
-              </a:rPr>
-              <a:t>[Nome completo]</a:t>
-            </a:r>
-            <a:endParaRPr lang="en-US" sz="1400" dirty="0"/>
-          </a:p>
-        </p:txBody>
-      </p:sp>
-      <p:sp>
-        <p:nvSpPr>
-          <p:cNvPr id="17" name="Text 15"/>
-          <p:cNvSpPr txBox="1"/>
-          <p:nvPr/>
-        </p:nvSpPr>
-        <p:spPr>
-          <a:xfrm>
-            <a:off x="6446520" y="3931920"/>
-            <a:ext cx="2331720" cy="822960"/>
-          </a:xfrm>
-          <a:prstGeom prst="rect">
-            <a:avLst/>
-          </a:prstGeom>
-          <a:noFill/>
-          <a:ln/>
-        </p:spPr>
-        <p:txBody>
-          <a:bodyPr wrap="square" lIns="0" tIns="0" rIns="0" bIns="0" rtlCol="0" anchor="ctr"/>
-          <a:lstStyle/>
-          <a:p>
-            <a:pPr algn="ctr" indent="0" marL="0">
-              <a:buNone/>
-            </a:pPr>
-            <a:r>
-              <a:rPr lang="en-US" sz="1250" dirty="0">
-                <a:solidFill>
-                  <a:srgbClr val="5B665E"/>
-                </a:solidFill>
-                <a:latin typeface="Calibri" pitchFamily="34" charset="0"/>
-                <a:ea typeface="Calibri" pitchFamily="34" charset="-122"/>
-                <a:cs typeface="Calibri" pitchFamily="34" charset="-120"/>
-              </a:rPr>
-              <a:t>[RM]</a:t>
-            </a:r>
-            <a:endParaRPr lang="en-US" sz="1250" dirty="0"/>
-          </a:p>
-          <a:p>
-            <a:pPr algn="ctr" indent="0" marL="0">
-              <a:buNone/>
-            </a:pPr>
-            <a:r>
-              <a:rPr lang="en-US" sz="1250" dirty="0">
-                <a:solidFill>
-                  <a:srgbClr val="5B665E"/>
-                </a:solidFill>
-                <a:latin typeface="Calibri" pitchFamily="34" charset="0"/>
-                <a:ea typeface="Calibri" pitchFamily="34" charset="-122"/>
-                <a:cs typeface="Calibri" pitchFamily="34" charset="-120"/>
-              </a:rPr>
-              <a:t>[Turma]</a:t>
-            </a:r>
-            <a:endParaRPr lang="en-US" sz="1250" dirty="0"/>
-          </a:p>
-        </p:txBody>
-      </p:sp>
-      <p:sp>
-        <p:nvSpPr>
-          <p:cNvPr id="18" name="Shape 16"/>
-          <p:cNvSpPr/>
-          <p:nvPr/>
-        </p:nvSpPr>
-        <p:spPr>
-          <a:xfrm>
-            <a:off x="9144000" y="1691640"/>
-            <a:ext cx="2606040" cy="3291840"/>
-          </a:xfrm>
-          <a:prstGeom prst="roundRect">
-            <a:avLst>
-              <a:gd name="adj" fmla="val 3509"/>
-            </a:avLst>
-          </a:prstGeom>
-          <a:solidFill>
-            <a:srgbClr val="F7F7F7"/>
-          </a:solidFill>
-          <a:ln w="12700">
-            <a:solidFill>
-              <a:srgbClr val="D9D9D9"/>
-            </a:solidFill>
-            <a:prstDash val="solid"/>
-          </a:ln>
-        </p:spPr>
-      </p:sp>
-      <p:sp>
-        <p:nvSpPr>
-          <p:cNvPr id="19" name="Shape 17"/>
-          <p:cNvSpPr/>
-          <p:nvPr/>
-        </p:nvSpPr>
-        <p:spPr>
-          <a:xfrm>
-            <a:off x="9852660" y="2011680"/>
-            <a:ext cx="1188720" cy="1188720"/>
-          </a:xfrm>
-          <a:prstGeom prst="ellipse">
-            <a:avLst/>
-          </a:prstGeom>
-          <a:solidFill>
-            <a:srgbClr val="D9D9D9"/>
-          </a:solidFill>
-          <a:ln/>
-        </p:spPr>
-      </p:sp>
-      <p:sp>
-        <p:nvSpPr>
-          <p:cNvPr id="20" name="Text 18"/>
-          <p:cNvSpPr txBox="1"/>
-          <p:nvPr/>
-        </p:nvSpPr>
-        <p:spPr>
-          <a:xfrm>
-            <a:off x="9852660" y="2011680"/>
-            <a:ext cx="1188720" cy="1188720"/>
-          </a:xfrm>
-          <a:prstGeom prst="rect">
-            <a:avLst/>
-          </a:prstGeom>
-          <a:noFill/>
-          <a:ln/>
-        </p:spPr>
-        <p:txBody>
-          <a:bodyPr wrap="square" lIns="0" tIns="0" rIns="0" bIns="0" rtlCol="0" anchor="ctr"/>
-          <a:lstStyle/>
-          <a:p>
-            <a:pPr algn="ctr" indent="0" marL="0">
-              <a:buNone/>
-            </a:pPr>
-            <a:r>
-              <a:rPr lang="en-US" sz="2600" b="1" dirty="0">
-                <a:solidFill>
-                  <a:srgbClr val="FFFFFF"/>
-                </a:solidFill>
-                <a:latin typeface="Calibri" pitchFamily="34" charset="0"/>
-                <a:ea typeface="Calibri" pitchFamily="34" charset="-122"/>
-                <a:cs typeface="Calibri" pitchFamily="34" charset="-120"/>
-              </a:rPr>
-              <a:t>?</a:t>
-            </a:r>
-            <a:endParaRPr lang="en-US" sz="2600" dirty="0"/>
-          </a:p>
-        </p:txBody>
-      </p:sp>
-      <p:sp>
-        <p:nvSpPr>
-          <p:cNvPr id="21" name="Text 19"/>
-          <p:cNvSpPr txBox="1"/>
-          <p:nvPr/>
-        </p:nvSpPr>
-        <p:spPr>
-          <a:xfrm>
-            <a:off x="9281160" y="3383280"/>
-            <a:ext cx="2331720" cy="548640"/>
-          </a:xfrm>
-          <a:prstGeom prst="rect">
-            <a:avLst/>
-          </a:prstGeom>
-          <a:noFill/>
-          <a:ln/>
-        </p:spPr>
-        <p:txBody>
-          <a:bodyPr wrap="square" lIns="0" tIns="0" rIns="0" bIns="0" rtlCol="0" anchor="ctr"/>
-          <a:lstStyle/>
-          <a:p>
-            <a:pPr algn="ctr" indent="0" marL="0">
-              <a:buNone/>
-            </a:pPr>
-            <a:r>
-              <a:rPr lang="en-US" sz="1400" b="1" dirty="0">
-                <a:solidFill>
-                  <a:srgbClr val="5B665E"/>
-                </a:solidFill>
-                <a:latin typeface="Calibri" pitchFamily="34" charset="0"/>
-                <a:ea typeface="Calibri" pitchFamily="34" charset="-122"/>
-                <a:cs typeface="Calibri" pitchFamily="34" charset="-120"/>
-              </a:rPr>
-              <a:t>[Nome completo]</a:t>
-            </a:r>
-            <a:endParaRPr lang="en-US" sz="1400" dirty="0"/>
-          </a:p>
-        </p:txBody>
-      </p:sp>
-      <p:sp>
-        <p:nvSpPr>
-          <p:cNvPr id="22" name="Text 20"/>
-          <p:cNvSpPr txBox="1"/>
-          <p:nvPr/>
-        </p:nvSpPr>
-        <p:spPr>
-          <a:xfrm>
-            <a:off x="9281160" y="3931920"/>
-            <a:ext cx="2331720" cy="822960"/>
-          </a:xfrm>
-          <a:prstGeom prst="rect">
-            <a:avLst/>
-          </a:prstGeom>
-          <a:noFill/>
-          <a:ln/>
-        </p:spPr>
-        <p:txBody>
-          <a:bodyPr wrap="square" lIns="0" tIns="0" rIns="0" bIns="0" rtlCol="0" anchor="ctr"/>
-          <a:lstStyle/>
-          <a:p>
-            <a:pPr algn="ctr" indent="0" marL="0">
-              <a:buNone/>
-            </a:pPr>
-            <a:r>
-              <a:rPr lang="en-US" sz="1250" dirty="0">
-                <a:solidFill>
-                  <a:srgbClr val="5B665E"/>
-                </a:solidFill>
-                <a:latin typeface="Calibri" pitchFamily="34" charset="0"/>
-                <a:ea typeface="Calibri" pitchFamily="34" charset="-122"/>
-                <a:cs typeface="Calibri" pitchFamily="34" charset="-120"/>
-              </a:rPr>
-              <a:t>[RM]</a:t>
-            </a:r>
-            <a:endParaRPr lang="en-US" sz="1250" dirty="0"/>
-          </a:p>
-          <a:p>
-            <a:pPr algn="ctr" indent="0" marL="0">
-              <a:buNone/>
-            </a:pPr>
-            <a:r>
-              <a:rPr lang="en-US" sz="1250" dirty="0">
-                <a:solidFill>
-                  <a:srgbClr val="5B665E"/>
-                </a:solidFill>
-                <a:latin typeface="Calibri" pitchFamily="34" charset="0"/>
-                <a:ea typeface="Calibri" pitchFamily="34" charset="-122"/>
-                <a:cs typeface="Calibri" pitchFamily="34" charset="-120"/>
-              </a:rPr>
-              <a:t>[Turma]</a:t>
-            </a:r>
-            <a:endParaRPr lang="en-US" sz="1250" dirty="0"/>
-          </a:p>
-        </p:txBody>
-      </p:sp>
-      <p:sp>
-        <p:nvSpPr>
-          <p:cNvPr id="23" name="Shape 21"/>
           <p:cNvSpPr/>
           <p:nvPr/>
         </p:nvSpPr>
@@ -6358,7 +5798,7 @@
       </p:sp>
       <p:sp>
         <p:nvSpPr>
-          <p:cNvPr id="24" name="Text 22"/>
+          <p:cNvPr id="9" name="Text 7"/>
           <p:cNvSpPr txBox="1"/>
           <p:nvPr/>
         </p:nvSpPr>
@@ -6397,7 +5837,7 @@
       </p:sp>
       <p:sp>
         <p:nvSpPr>
-          <p:cNvPr id="25" name="Text 23"/>
+          <p:cNvPr id="10" name="Text 8"/>
           <p:cNvSpPr txBox="1"/>
           <p:nvPr/>
         </p:nvSpPr>
@@ -6428,7 +5868,7 @@
                 <a:ea typeface="Calibri" pitchFamily="34" charset="-122"/>
                 <a:cs typeface="Calibri" pitchFamily="34" charset="-120"/>
               </a:rPr>
-              <a:t>Quem construiu o projeto</a:t>
+              <a:t>Quem construiu este projeto</a:t>
             </a:r>
             <a:endParaRPr lang="en-US" sz="1000" dirty="0"/>
           </a:p>
@@ -6436,7 +5876,7 @@
       </p:sp>
       <p:sp>
         <p:nvSpPr>
-          <p:cNvPr id="26" name="Text 24"/>
+          <p:cNvPr id="11" name="Text 9"/>
           <p:cNvSpPr txBox="1"/>
           <p:nvPr/>
         </p:nvSpPr>

</xml_diff>